<commit_message>
minor updates to powerpoint_presentations/PythonOverview.pptx
</commit_message>
<xml_diff>
--- a/powerpoint_presentations/PythonOverview.pptx
+++ b/powerpoint_presentations/PythonOverview.pptx
@@ -264,14 +264,14 @@
           <a:effectLst/>
           <a:extLst>
             <a:ext uri="{909E8E84-426E-40dd-AFC4-6F175D3DCCD1}">
-              <a14:hiddenFill xmlns="" xmlns:a14="http://schemas.microsoft.com/office/drawing/2010/main">
+              <a14:hiddenFill xmlns:a14="http://schemas.microsoft.com/office/drawing/2010/main" xmlns="">
                 <a:solidFill>
                   <a:schemeClr val="accent1"/>
                 </a:solidFill>
               </a14:hiddenFill>
             </a:ext>
             <a:ext uri="{91240B29-F687-4f45-9708-019B960494DF}">
-              <a14:hiddenLine xmlns="" xmlns:a14="http://schemas.microsoft.com/office/drawing/2010/main" w="12700">
+              <a14:hiddenLine xmlns:a14="http://schemas.microsoft.com/office/drawing/2010/main" xmlns="" w="12700">
                 <a:solidFill>
                   <a:schemeClr val="tx1"/>
                 </a:solidFill>
@@ -281,7 +281,7 @@
               </a14:hiddenLine>
             </a:ext>
             <a:ext uri="{AF507438-7753-43e0-B8FC-AC1667EBCBE1}">
-              <a14:hiddenEffects xmlns="" xmlns:a14="http://schemas.microsoft.com/office/drawing/2010/main">
+              <a14:hiddenEffects xmlns:a14="http://schemas.microsoft.com/office/drawing/2010/main" xmlns="">
                 <a:effectLst>
                   <a:outerShdw blurRad="63500" dist="38099" dir="2700000" algn="ctr" rotWithShape="0">
                     <a:schemeClr val="bg2">
@@ -292,7 +292,7 @@
               </a14:hiddenEffects>
             </a:ext>
             <a:ext uri="{FAA26D3D-D897-4be2-8F04-BA451C77F1D7}">
-              <ma14:placeholderFlag xmlns="" xmlns:ma14="http://schemas.microsoft.com/office/mac/drawingml/2011/main" val="1"/>
+              <ma14:placeholderFlag xmlns:ma14="http://schemas.microsoft.com/office/mac/drawingml/2011/main" xmlns="" val="1"/>
             </a:ext>
           </a:extLst>
         </p:spPr>
@@ -370,12 +370,12 @@
           <a:effectLst/>
           <a:extLst>
             <a:ext uri="{909E8E84-426E-40dd-AFC4-6F175D3DCCD1}">
-              <a14:hiddenFill xmlns="" xmlns:a14="http://schemas.microsoft.com/office/drawing/2010/main">
+              <a14:hiddenFill xmlns:a14="http://schemas.microsoft.com/office/drawing/2010/main" xmlns="">
                 <a:noFill/>
               </a14:hiddenFill>
             </a:ext>
             <a:ext uri="{AF507438-7753-43e0-B8FC-AC1667EBCBE1}">
-              <a14:hiddenEffects xmlns="" xmlns:a14="http://schemas.microsoft.com/office/drawing/2010/main">
+              <a14:hiddenEffects xmlns:a14="http://schemas.microsoft.com/office/drawing/2010/main" xmlns="">
                 <a:effectLst>
                   <a:outerShdw blurRad="63500" dist="38099" dir="2700000" algn="ctr" rotWithShape="0">
                     <a:srgbClr val="000000">
@@ -386,7 +386,7 @@
               </a14:hiddenEffects>
             </a:ext>
             <a:ext uri="{53640926-AAD7-44d8-BBD7-CCE9431645EC}">
-              <a14:shadowObscured xmlns="" xmlns:a14="http://schemas.microsoft.com/office/drawing/2010/main" val="1"/>
+              <a14:shadowObscured xmlns:a14="http://schemas.microsoft.com/office/drawing/2010/main" xmlns="" val="1"/>
             </a:ext>
           </a:extLst>
         </p:spPr>
@@ -3114,14 +3114,14 @@
           </a:ln>
           <a:extLst>
             <a:ext uri="{909E8E84-426E-40dd-AFC4-6F175D3DCCD1}">
-              <a14:hiddenFill xmlns="" xmlns:a14="http://schemas.microsoft.com/office/drawing/2010/main">
+              <a14:hiddenFill xmlns:a14="http://schemas.microsoft.com/office/drawing/2010/main" xmlns="">
                 <a:solidFill>
                   <a:srgbClr val="FFFFFF"/>
                 </a:solidFill>
               </a14:hiddenFill>
             </a:ext>
             <a:ext uri="{91240B29-F687-4f45-9708-019B960494DF}">
-              <a14:hiddenLine xmlns="" xmlns:a14="http://schemas.microsoft.com/office/drawing/2010/main" w="9525">
+              <a14:hiddenLine xmlns:a14="http://schemas.microsoft.com/office/drawing/2010/main" xmlns="" w="9525">
                 <a:solidFill>
                   <a:srgbClr val="000000"/>
                 </a:solidFill>
@@ -4766,14 +4766,14 @@
           <a:effectLst/>
           <a:extLst>
             <a:ext uri="{909E8E84-426E-40dd-AFC4-6F175D3DCCD1}">
-              <a14:hiddenFill xmlns="" xmlns:a14="http://schemas.microsoft.com/office/drawing/2010/main">
+              <a14:hiddenFill xmlns:a14="http://schemas.microsoft.com/office/drawing/2010/main" xmlns="">
                 <a:solidFill>
                   <a:schemeClr val="accent1"/>
                 </a:solidFill>
               </a14:hiddenFill>
             </a:ext>
             <a:ext uri="{91240B29-F687-4f45-9708-019B960494DF}">
-              <a14:hiddenLine xmlns="" xmlns:a14="http://schemas.microsoft.com/office/drawing/2010/main" w="12700">
+              <a14:hiddenLine xmlns:a14="http://schemas.microsoft.com/office/drawing/2010/main" xmlns="" w="12700">
                 <a:solidFill>
                   <a:schemeClr val="tx1"/>
                 </a:solidFill>
@@ -4783,7 +4783,7 @@
               </a14:hiddenLine>
             </a:ext>
             <a:ext uri="{AF507438-7753-43e0-B8FC-AC1667EBCBE1}">
-              <a14:hiddenEffects xmlns="" xmlns:a14="http://schemas.microsoft.com/office/drawing/2010/main">
+              <a14:hiddenEffects xmlns:a14="http://schemas.microsoft.com/office/drawing/2010/main" xmlns="">
                 <a:effectLst>
                   <a:outerShdw blurRad="63500" dist="38099" dir="2700000" algn="ctr" rotWithShape="0">
                     <a:schemeClr val="bg2">
@@ -4794,7 +4794,7 @@
               </a14:hiddenEffects>
             </a:ext>
             <a:ext uri="{FAA26D3D-D897-4be2-8F04-BA451C77F1D7}">
-              <ma14:placeholderFlag xmlns="" xmlns:ma14="http://schemas.microsoft.com/office/mac/drawingml/2011/main" val="1"/>
+              <ma14:placeholderFlag xmlns:ma14="http://schemas.microsoft.com/office/mac/drawingml/2011/main" xmlns="" val="1"/>
             </a:ext>
           </a:extLst>
         </p:spPr>
@@ -4839,14 +4839,14 @@
           <a:effectLst/>
           <a:extLst>
             <a:ext uri="{909E8E84-426E-40dd-AFC4-6F175D3DCCD1}">
-              <a14:hiddenFill xmlns="" xmlns:a14="http://schemas.microsoft.com/office/drawing/2010/main">
+              <a14:hiddenFill xmlns:a14="http://schemas.microsoft.com/office/drawing/2010/main" xmlns="">
                 <a:solidFill>
                   <a:schemeClr val="accent1"/>
                 </a:solidFill>
               </a14:hiddenFill>
             </a:ext>
             <a:ext uri="{91240B29-F687-4f45-9708-019B960494DF}">
-              <a14:hiddenLine xmlns="" xmlns:a14="http://schemas.microsoft.com/office/drawing/2010/main" w="12700">
+              <a14:hiddenLine xmlns:a14="http://schemas.microsoft.com/office/drawing/2010/main" xmlns="" w="12700">
                 <a:solidFill>
                   <a:schemeClr val="tx1"/>
                 </a:solidFill>
@@ -4856,7 +4856,7 @@
               </a14:hiddenLine>
             </a:ext>
             <a:ext uri="{AF507438-7753-43e0-B8FC-AC1667EBCBE1}">
-              <a14:hiddenEffects xmlns="" xmlns:a14="http://schemas.microsoft.com/office/drawing/2010/main">
+              <a14:hiddenEffects xmlns:a14="http://schemas.microsoft.com/office/drawing/2010/main" xmlns="">
                 <a:effectLst>
                   <a:outerShdw blurRad="63500" dist="38099" dir="2700000" algn="ctr" rotWithShape="0">
                     <a:schemeClr val="bg2">
@@ -4867,7 +4867,7 @@
               </a14:hiddenEffects>
             </a:ext>
             <a:ext uri="{FAA26D3D-D897-4be2-8F04-BA451C77F1D7}">
-              <ma14:placeholderFlag xmlns="" xmlns:ma14="http://schemas.microsoft.com/office/mac/drawingml/2011/main" val="1"/>
+              <ma14:placeholderFlag xmlns:ma14="http://schemas.microsoft.com/office/mac/drawingml/2011/main" xmlns="" val="1"/>
             </a:ext>
           </a:extLst>
         </p:spPr>
@@ -4951,14 +4951,14 @@
           </a:ln>
           <a:extLst>
             <a:ext uri="{909E8E84-426E-40dd-AFC4-6F175D3DCCD1}">
-              <a14:hiddenFill xmlns="" xmlns:a14="http://schemas.microsoft.com/office/drawing/2010/main">
+              <a14:hiddenFill xmlns:a14="http://schemas.microsoft.com/office/drawing/2010/main" xmlns="">
                 <a:solidFill>
                   <a:srgbClr val="FFFFFF"/>
                 </a:solidFill>
               </a14:hiddenFill>
             </a:ext>
             <a:ext uri="{91240B29-F687-4f45-9708-019B960494DF}">
-              <a14:hiddenLine xmlns="" xmlns:a14="http://schemas.microsoft.com/office/drawing/2010/main" w="9525">
+              <a14:hiddenLine xmlns:a14="http://schemas.microsoft.com/office/drawing/2010/main" xmlns="" w="9525">
                 <a:solidFill>
                   <a:srgbClr val="000000"/>
                 </a:solidFill>
@@ -5541,7 +5541,7 @@
               <a:rPr lang="en-US" sz="2400" b="0" dirty="0">
                 <a:cs typeface="+mn-cs"/>
               </a:rPr>
-              <a:t>Madison, WI, Sept. 22–26, 2025</a:t>
+              <a:t>Portland, OR, Aug. 10-12, 2026</a:t>
             </a:r>
           </a:p>
           <a:p>
@@ -5583,14 +5583,14 @@
           <a:effectLst/>
           <a:extLst>
             <a:ext uri="{909E8E84-426E-40dd-AFC4-6F175D3DCCD1}">
-              <a14:hiddenFill xmlns="" xmlns:a14="http://schemas.microsoft.com/office/drawing/2010/main">
+              <a14:hiddenFill xmlns:a14="http://schemas.microsoft.com/office/drawing/2010/main" xmlns="">
                 <a:solidFill>
                   <a:schemeClr val="accent1"/>
                 </a:solidFill>
               </a14:hiddenFill>
             </a:ext>
             <a:ext uri="{91240B29-F687-4f45-9708-019B960494DF}">
-              <a14:hiddenLine xmlns="" xmlns:a14="http://schemas.microsoft.com/office/drawing/2010/main" w="12700">
+              <a14:hiddenLine xmlns:a14="http://schemas.microsoft.com/office/drawing/2010/main" xmlns="" w="12700">
                 <a:solidFill>
                   <a:schemeClr val="tx1"/>
                 </a:solidFill>
@@ -5600,7 +5600,7 @@
               </a14:hiddenLine>
             </a:ext>
             <a:ext uri="{AF507438-7753-43e0-B8FC-AC1667EBCBE1}">
-              <a14:hiddenEffects xmlns="" xmlns:a14="http://schemas.microsoft.com/office/drawing/2010/main">
+              <a14:hiddenEffects xmlns:a14="http://schemas.microsoft.com/office/drawing/2010/main" xmlns="">
                 <a:effectLst>
                   <a:outerShdw blurRad="63500" dist="38099" dir="2700000" algn="ctr" rotWithShape="0">
                     <a:schemeClr val="bg2">
@@ -5611,7 +5611,7 @@
               </a14:hiddenEffects>
             </a:ext>
             <a:ext uri="{FAA26D3D-D897-4be2-8F04-BA451C77F1D7}">
-              <ma14:placeholderFlag xmlns="" xmlns:ma14="http://schemas.microsoft.com/office/mac/drawingml/2011/main" val="1"/>
+              <ma14:placeholderFlag xmlns:ma14="http://schemas.microsoft.com/office/mac/drawingml/2011/main" xmlns="" val="1"/>
             </a:ext>
           </a:extLst>
         </p:spPr>
@@ -6531,14 +6531,14 @@
           <a:effectLst/>
           <a:extLst>
             <a:ext uri="{909E8E84-426E-40dd-AFC4-6F175D3DCCD1}">
-              <a14:hiddenFill xmlns="" xmlns:a14="http://schemas.microsoft.com/office/drawing/2010/main">
+              <a14:hiddenFill xmlns:a14="http://schemas.microsoft.com/office/drawing/2010/main" xmlns="">
                 <a:solidFill>
                   <a:schemeClr val="accent1"/>
                 </a:solidFill>
               </a14:hiddenFill>
             </a:ext>
             <a:ext uri="{91240B29-F687-4f45-9708-019B960494DF}">
-              <a14:hiddenLine xmlns="" xmlns:a14="http://schemas.microsoft.com/office/drawing/2010/main" w="12700">
+              <a14:hiddenLine xmlns:a14="http://schemas.microsoft.com/office/drawing/2010/main" xmlns="" w="12700">
                 <a:solidFill>
                   <a:schemeClr val="tx1"/>
                 </a:solidFill>
@@ -6548,7 +6548,7 @@
               </a14:hiddenLine>
             </a:ext>
             <a:ext uri="{AF507438-7753-43e0-B8FC-AC1667EBCBE1}">
-              <a14:hiddenEffects xmlns="" xmlns:a14="http://schemas.microsoft.com/office/drawing/2010/main">
+              <a14:hiddenEffects xmlns:a14="http://schemas.microsoft.com/office/drawing/2010/main" xmlns="">
                 <a:effectLst>
                   <a:outerShdw blurRad="63500" dist="38099" dir="2700000" algn="ctr" rotWithShape="0">
                     <a:schemeClr val="bg2">
@@ -6559,7 +6559,7 @@
               </a14:hiddenEffects>
             </a:ext>
             <a:ext uri="{FAA26D3D-D897-4be2-8F04-BA451C77F1D7}">
-              <ma14:placeholderFlag xmlns="" xmlns:ma14="http://schemas.microsoft.com/office/mac/drawingml/2011/main" val="1"/>
+              <ma14:placeholderFlag xmlns:ma14="http://schemas.microsoft.com/office/mac/drawingml/2011/main" xmlns="" val="1"/>
             </a:ext>
           </a:extLst>
         </p:spPr>
@@ -6823,15 +6823,27 @@
           </a:p>
           <a:p>
             <a:r>
-              <a:rPr lang="en-US" sz="2400" b="0" kern="0" dirty="0"/>
+              <a:rPr lang="en-US" sz="2400" b="0" kern="0" dirty="0">
+                <a:solidFill>
+                  <a:srgbClr val="FFFF00"/>
+                </a:solidFill>
+              </a:rPr>
               <a:t>Just use </a:t>
             </a:r>
             <a:r>
-              <a:rPr lang="en-US" sz="2400" kern="0" dirty="0" err="1"/>
+              <a:rPr lang="en-US" sz="2400" kern="0" dirty="0" err="1">
+                <a:solidFill>
+                  <a:srgbClr val="FFFF00"/>
+                </a:solidFill>
+              </a:rPr>
               <a:t>Miniforge</a:t>
             </a:r>
             <a:r>
-              <a:rPr lang="en-US" sz="2400" b="0" kern="0" dirty="0"/>
+              <a:rPr lang="en-US" sz="2400" b="0" kern="0" dirty="0">
+                <a:solidFill>
+                  <a:srgbClr val="FFFF00"/>
+                </a:solidFill>
+              </a:rPr>
               <a:t>!</a:t>
             </a:r>
           </a:p>
@@ -7069,7 +7081,11 @@
           </a:p>
           <a:p>
             <a:r>
-              <a:rPr lang="en-US" sz="2300" b="0" dirty="0"/>
+              <a:rPr lang="en-US" sz="2300" b="0" dirty="0">
+                <a:solidFill>
+                  <a:srgbClr val="FFFF00"/>
+                </a:solidFill>
+              </a:rPr>
               <a:t>Conda now uses the mamba solver by default</a:t>
             </a:r>
           </a:p>
@@ -7365,15 +7381,7 @@
             <a:pPr lvl="1"/>
             <a:r>
               <a:rPr lang="en-US" sz="1600" b="0" dirty="0"/>
-              <a:t>Anaconda (company that first developed Conda) </a:t>
-            </a:r>
-            <a:r>
-              <a:rPr lang="en-US" sz="1600" b="0"/>
-              <a:t>has its </a:t>
-            </a:r>
-            <a:r>
-              <a:rPr lang="en-US" sz="1600" b="0" dirty="0"/>
-              <a:t>own ”defaults” channel; “</a:t>
+              <a:t>Anaconda (company that first developed Conda) has its own ”defaults” channel; “</a:t>
             </a:r>
             <a:r>
               <a:rPr lang="en-US" sz="1600" b="0" dirty="0" err="1"/>
@@ -7434,15 +7442,27 @@
           </a:p>
           <a:p>
             <a:r>
-              <a:rPr lang="en-US" sz="2000" b="0" dirty="0"/>
+              <a:rPr lang="en-US" sz="2000" b="0" dirty="0">
+                <a:solidFill>
+                  <a:srgbClr val="FFFF00"/>
+                </a:solidFill>
+              </a:rPr>
               <a:t>Best practice is to stick to single channel; only use pip for packages not on </a:t>
             </a:r>
             <a:r>
-              <a:rPr lang="en-US" sz="2000" b="0" dirty="0" err="1"/>
+              <a:rPr lang="en-US" sz="2000" b="0" dirty="0" err="1">
+                <a:solidFill>
+                  <a:srgbClr val="FFFF00"/>
+                </a:solidFill>
+              </a:rPr>
               <a:t>conda</a:t>
             </a:r>
             <a:r>
-              <a:rPr lang="en-US" sz="2000" b="0" dirty="0"/>
+              <a:rPr lang="en-US" sz="2000" b="0" dirty="0">
+                <a:solidFill>
+                  <a:srgbClr val="FFFF00"/>
+                </a:solidFill>
+              </a:rPr>
               <a:t>-forge</a:t>
             </a:r>
           </a:p>
@@ -7653,7 +7673,7 @@
             </a:r>
             <a:r>
               <a:rPr lang="en-US" sz="2000" b="0" dirty="0"/>
-              <a:t>environment with extra packages for testing the course content and building t</a:t>
+              <a:t>environment with extra packages for testing the course content and building the HTML pages</a:t>
             </a:r>
           </a:p>
           <a:p>
@@ -7676,11 +7696,18 @@
           </a:p>
           <a:p>
             <a:r>
-              <a:rPr lang="en-US" sz="2400" b="0" dirty="0"/>
+              <a:rPr lang="en-US" sz="2400" b="0" dirty="0">
+                <a:solidFill>
+                  <a:srgbClr val="FFFF00"/>
+                </a:solidFill>
+              </a:rPr>
               <a:t>Best practice is to leave the </a:t>
             </a:r>
             <a:r>
               <a:rPr lang="en-US" sz="2400" b="0" dirty="0">
+                <a:solidFill>
+                  <a:srgbClr val="FFFF00"/>
+                </a:solidFill>
                 <a:latin typeface="Menlo" panose="020B0609030804020204" pitchFamily="49" charset="0"/>
                 <a:ea typeface="Menlo" panose="020B0609030804020204" pitchFamily="49" charset="0"/>
                 <a:cs typeface="Menlo" panose="020B0609030804020204" pitchFamily="49" charset="0"/>
@@ -7688,7 +7715,11 @@
               <a:t>base</a:t>
             </a:r>
             <a:r>
-              <a:rPr lang="en-US" sz="2400" b="0" dirty="0"/>
+              <a:rPr lang="en-US" sz="2400" b="0" dirty="0">
+                <a:solidFill>
+                  <a:srgbClr val="FFFF00"/>
+                </a:solidFill>
+              </a:rPr>
               <a:t> alone and make new environments for each project</a:t>
             </a:r>
           </a:p>
@@ -7774,7 +7805,7 @@
           <a:p>
             <a:r>
               <a:rPr lang="en-US" dirty="0"/>
-              <a:t>We are using Python 3.12 for the class</a:t>
+              <a:t>We are using Python 3.14 for the class</a:t>
             </a:r>
           </a:p>
         </p:txBody>
@@ -7888,14 +7919,14 @@
                 <a:cs typeface="Arial" panose="020B0604020202020204" pitchFamily="34" charset="0"/>
                 <a:hlinkClick r:id="rId3"/>
               </a:rPr>
-              <a:t>this recent debate </a:t>
+              <a:t>this debate </a:t>
             </a:r>
             <a:r>
               <a:rPr lang="en-US" dirty="0">
                 <a:latin typeface="Arial" panose="020B0604020202020204" pitchFamily="34" charset="0"/>
                 <a:cs typeface="Arial" panose="020B0604020202020204" pitchFamily="34" charset="0"/>
               </a:rPr>
-              <a:t>about GUIs vs scripting</a:t>
+              <a:t>about groundwater modeling with GUIs vs scripting</a:t>
             </a:r>
             <a:endParaRPr lang="en-US" sz="2400" dirty="0"/>
           </a:p>
@@ -7976,6 +8007,484 @@
             <a:extLst>
               <a:ext uri="{FF2B5EF4-FFF2-40B4-BE49-F238E27FC236}">
                 <a16:creationId xmlns:a16="http://schemas.microsoft.com/office/drawing/2014/main" id="{05C3E832-2748-3110-94C5-41987FF5E548}"/>
+              </a:ext>
+            </a:extLst>
+          </p:cNvPr>
+          <p:cNvSpPr txBox="1">
+            <a:spLocks/>
+          </p:cNvSpPr>
+          <p:nvPr/>
+        </p:nvSpPr>
+        <p:spPr bwMode="auto">
+          <a:xfrm>
+            <a:off x="304800" y="115669"/>
+            <a:ext cx="8305800" cy="1143000"/>
+          </a:xfrm>
+          <a:prstGeom prst="rect">
+            <a:avLst/>
+          </a:prstGeom>
+          <a:noFill/>
+          <a:ln>
+            <a:noFill/>
+          </a:ln>
+          <a:effectLst/>
+          <a:extLst>
+            <a:ext uri="{909E8E84-426E-40dd-AFC4-6F175D3DCCD1}">
+              <a14:hiddenFill xmlns:a14="http://schemas.microsoft.com/office/drawing/2010/main" xmlns="">
+                <a:solidFill>
+                  <a:schemeClr val="accent1"/>
+                </a:solidFill>
+              </a14:hiddenFill>
+            </a:ext>
+            <a:ext uri="{91240B29-F687-4f45-9708-019B960494DF}">
+              <a14:hiddenLine xmlns:a14="http://schemas.microsoft.com/office/drawing/2010/main" xmlns="" w="12700">
+                <a:solidFill>
+                  <a:schemeClr val="tx1"/>
+                </a:solidFill>
+                <a:miter lim="800000"/>
+                <a:headEnd/>
+                <a:tailEnd/>
+              </a14:hiddenLine>
+            </a:ext>
+            <a:ext uri="{AF507438-7753-43e0-B8FC-AC1667EBCBE1}">
+              <a14:hiddenEffects xmlns:a14="http://schemas.microsoft.com/office/drawing/2010/main" xmlns="">
+                <a:effectLst>
+                  <a:outerShdw blurRad="63500" dist="38099" dir="2700000" algn="ctr" rotWithShape="0">
+                    <a:schemeClr val="bg2">
+                      <a:alpha val="74998"/>
+                    </a:schemeClr>
+                  </a:outerShdw>
+                </a:effectLst>
+              </a14:hiddenEffects>
+            </a:ext>
+            <a:ext uri="{FAA26D3D-D897-4be2-8F04-BA451C77F1D7}">
+              <ma14:placeholderFlag xmlns:ma14="http://schemas.microsoft.com/office/mac/drawingml/2011/main" xmlns="" val="1"/>
+            </a:ext>
+          </a:extLst>
+        </p:spPr>
+        <p:txBody>
+          <a:bodyPr vert="horz" wrap="square" lIns="90488" tIns="44450" rIns="90488" bIns="44450" numCol="1" anchor="ctr" anchorCtr="0" compatLnSpc="1">
+            <a:prstTxWarp prst="textNoShape">
+              <a:avLst/>
+            </a:prstTxWarp>
+          </a:bodyPr>
+          <a:lstStyle>
+            <a:lvl1pPr algn="l" rtl="0" eaLnBrk="0" fontAlgn="base" hangingPunct="0">
+              <a:spcBef>
+                <a:spcPct val="0"/>
+              </a:spcBef>
+              <a:spcAft>
+                <a:spcPct val="0"/>
+              </a:spcAft>
+              <a:defRPr sz="3600" b="1">
+                <a:solidFill>
+                  <a:srgbClr val="FFFF99"/>
+                </a:solidFill>
+                <a:latin typeface="+mj-lt"/>
+                <a:ea typeface="+mj-ea"/>
+                <a:cs typeface="ＭＳ Ｐゴシック" charset="0"/>
+              </a:defRPr>
+            </a:lvl1pPr>
+            <a:lvl2pPr algn="l" rtl="0" eaLnBrk="0" fontAlgn="base" hangingPunct="0">
+              <a:spcBef>
+                <a:spcPct val="0"/>
+              </a:spcBef>
+              <a:spcAft>
+                <a:spcPct val="0"/>
+              </a:spcAft>
+              <a:defRPr sz="3600" b="1">
+                <a:solidFill>
+                  <a:srgbClr val="FFFF99"/>
+                </a:solidFill>
+                <a:latin typeface="Arial" charset="0"/>
+                <a:ea typeface="ＭＳ Ｐゴシック" charset="0"/>
+                <a:cs typeface="ＭＳ Ｐゴシック" charset="0"/>
+              </a:defRPr>
+            </a:lvl2pPr>
+            <a:lvl3pPr algn="l" rtl="0" eaLnBrk="0" fontAlgn="base" hangingPunct="0">
+              <a:spcBef>
+                <a:spcPct val="0"/>
+              </a:spcBef>
+              <a:spcAft>
+                <a:spcPct val="0"/>
+              </a:spcAft>
+              <a:defRPr sz="3600" b="1">
+                <a:solidFill>
+                  <a:srgbClr val="FFFF99"/>
+                </a:solidFill>
+                <a:latin typeface="Arial" charset="0"/>
+                <a:ea typeface="ＭＳ Ｐゴシック" charset="0"/>
+                <a:cs typeface="ＭＳ Ｐゴシック" charset="0"/>
+              </a:defRPr>
+            </a:lvl3pPr>
+            <a:lvl4pPr algn="l" rtl="0" eaLnBrk="0" fontAlgn="base" hangingPunct="0">
+              <a:spcBef>
+                <a:spcPct val="0"/>
+              </a:spcBef>
+              <a:spcAft>
+                <a:spcPct val="0"/>
+              </a:spcAft>
+              <a:defRPr sz="3600" b="1">
+                <a:solidFill>
+                  <a:srgbClr val="FFFF99"/>
+                </a:solidFill>
+                <a:latin typeface="Arial" charset="0"/>
+                <a:ea typeface="ＭＳ Ｐゴシック" charset="0"/>
+                <a:cs typeface="ＭＳ Ｐゴシック" charset="0"/>
+              </a:defRPr>
+            </a:lvl4pPr>
+            <a:lvl5pPr algn="l" rtl="0" eaLnBrk="0" fontAlgn="base" hangingPunct="0">
+              <a:spcBef>
+                <a:spcPct val="0"/>
+              </a:spcBef>
+              <a:spcAft>
+                <a:spcPct val="0"/>
+              </a:spcAft>
+              <a:defRPr sz="3600" b="1">
+                <a:solidFill>
+                  <a:srgbClr val="FFFF99"/>
+                </a:solidFill>
+                <a:latin typeface="Arial" charset="0"/>
+                <a:ea typeface="ＭＳ Ｐゴシック" charset="0"/>
+                <a:cs typeface="ＭＳ Ｐゴシック" charset="0"/>
+              </a:defRPr>
+            </a:lvl5pPr>
+            <a:lvl6pPr marL="457200" algn="l" rtl="0" eaLnBrk="0" fontAlgn="base" hangingPunct="0">
+              <a:spcBef>
+                <a:spcPct val="0"/>
+              </a:spcBef>
+              <a:spcAft>
+                <a:spcPct val="0"/>
+              </a:spcAft>
+              <a:defRPr sz="3600" b="1">
+                <a:solidFill>
+                  <a:srgbClr val="FFFF99"/>
+                </a:solidFill>
+                <a:latin typeface="Arial" charset="0"/>
+                <a:ea typeface="ＭＳ Ｐゴシック" charset="0"/>
+              </a:defRPr>
+            </a:lvl6pPr>
+            <a:lvl7pPr marL="914400" algn="l" rtl="0" eaLnBrk="0" fontAlgn="base" hangingPunct="0">
+              <a:spcBef>
+                <a:spcPct val="0"/>
+              </a:spcBef>
+              <a:spcAft>
+                <a:spcPct val="0"/>
+              </a:spcAft>
+              <a:defRPr sz="3600" b="1">
+                <a:solidFill>
+                  <a:srgbClr val="FFFF99"/>
+                </a:solidFill>
+                <a:latin typeface="Arial" charset="0"/>
+                <a:ea typeface="ＭＳ Ｐゴシック" charset="0"/>
+              </a:defRPr>
+            </a:lvl7pPr>
+            <a:lvl8pPr marL="1371600" algn="l" rtl="0" eaLnBrk="0" fontAlgn="base" hangingPunct="0">
+              <a:spcBef>
+                <a:spcPct val="0"/>
+              </a:spcBef>
+              <a:spcAft>
+                <a:spcPct val="0"/>
+              </a:spcAft>
+              <a:defRPr sz="3600" b="1">
+                <a:solidFill>
+                  <a:srgbClr val="FFFF99"/>
+                </a:solidFill>
+                <a:latin typeface="Arial" charset="0"/>
+                <a:ea typeface="ＭＳ Ｐゴシック" charset="0"/>
+              </a:defRPr>
+            </a:lvl8pPr>
+            <a:lvl9pPr marL="1828800" algn="l" rtl="0" eaLnBrk="0" fontAlgn="base" hangingPunct="0">
+              <a:spcBef>
+                <a:spcPct val="0"/>
+              </a:spcBef>
+              <a:spcAft>
+                <a:spcPct val="0"/>
+              </a:spcAft>
+              <a:defRPr sz="3600" b="1">
+                <a:solidFill>
+                  <a:srgbClr val="FFFF99"/>
+                </a:solidFill>
+                <a:latin typeface="Arial" charset="0"/>
+                <a:ea typeface="ＭＳ Ｐゴシック" charset="0"/>
+              </a:defRPr>
+            </a:lvl9pPr>
+          </a:lstStyle>
+          <a:p>
+            <a:r>
+              <a:rPr lang="en-US" kern="0" dirty="0"/>
+              <a:t>Repeatability is critical for good science</a:t>
+            </a:r>
+          </a:p>
+        </p:txBody>
+      </p:sp>
+      <p:sp>
+        <p:nvSpPr>
+          <p:cNvPr id="4" name="TextBox 3">
+            <a:extLst>
+              <a:ext uri="{FF2B5EF4-FFF2-40B4-BE49-F238E27FC236}">
+                <a16:creationId xmlns:a16="http://schemas.microsoft.com/office/drawing/2014/main" id="{D0997DCB-4F21-6F0F-1473-D3B47EE203B4}"/>
+              </a:ext>
+            </a:extLst>
+          </p:cNvPr>
+          <p:cNvSpPr txBox="1"/>
+          <p:nvPr/>
+        </p:nvSpPr>
+        <p:spPr>
+          <a:xfrm>
+            <a:off x="4343400" y="6096000"/>
+            <a:ext cx="4572000" cy="646331"/>
+          </a:xfrm>
+          <a:prstGeom prst="rect">
+            <a:avLst/>
+          </a:prstGeom>
+          <a:noFill/>
+        </p:spPr>
+        <p:txBody>
+          <a:bodyPr wrap="square">
+            <a:spAutoFit/>
+          </a:bodyPr>
+          <a:lstStyle/>
+          <a:p>
+            <a:pPr algn="r"/>
+            <a:r>
+              <a:rPr lang="en-US" sz="1200" b="0" i="0" dirty="0" err="1">
+                <a:solidFill>
+                  <a:schemeClr val="bg1"/>
+                </a:solidFill>
+                <a:effectLst/>
+                <a:latin typeface="Arial" panose="020B0604020202020204" pitchFamily="34" charset="0"/>
+                <a:cs typeface="Arial" panose="020B0604020202020204" pitchFamily="34" charset="0"/>
+              </a:rPr>
+              <a:t>Buckheit</a:t>
+            </a:r>
+            <a:r>
+              <a:rPr lang="en-US" sz="1200" b="0" i="0" dirty="0">
+                <a:solidFill>
+                  <a:schemeClr val="bg1"/>
+                </a:solidFill>
+                <a:effectLst/>
+                <a:latin typeface="Arial" panose="020B0604020202020204" pitchFamily="34" charset="0"/>
+                <a:cs typeface="Arial" panose="020B0604020202020204" pitchFamily="34" charset="0"/>
+              </a:rPr>
+              <a:t> JB, </a:t>
+            </a:r>
+            <a:r>
+              <a:rPr lang="en-US" sz="1200" b="0" i="0" dirty="0" err="1">
+                <a:solidFill>
+                  <a:schemeClr val="bg1"/>
+                </a:solidFill>
+                <a:effectLst/>
+                <a:latin typeface="Arial" panose="020B0604020202020204" pitchFamily="34" charset="0"/>
+                <a:cs typeface="Arial" panose="020B0604020202020204" pitchFamily="34" charset="0"/>
+              </a:rPr>
+              <a:t>Donoho</a:t>
+            </a:r>
+            <a:r>
+              <a:rPr lang="en-US" sz="1200" b="0" i="0" dirty="0">
+                <a:solidFill>
+                  <a:schemeClr val="bg1"/>
+                </a:solidFill>
+                <a:effectLst/>
+                <a:latin typeface="Arial" panose="020B0604020202020204" pitchFamily="34" charset="0"/>
+                <a:cs typeface="Arial" panose="020B0604020202020204" pitchFamily="34" charset="0"/>
+              </a:rPr>
+              <a:t> DL. </a:t>
+            </a:r>
+            <a:r>
+              <a:rPr lang="en-US" sz="1200" b="1" i="0" dirty="0">
+                <a:solidFill>
+                  <a:schemeClr val="bg1"/>
+                </a:solidFill>
+                <a:effectLst/>
+                <a:latin typeface="Arial" panose="020B0604020202020204" pitchFamily="34" charset="0"/>
+                <a:cs typeface="Arial" panose="020B0604020202020204" pitchFamily="34" charset="0"/>
+              </a:rPr>
+              <a:t>1995</a:t>
+            </a:r>
+            <a:r>
+              <a:rPr lang="en-US" sz="1200" b="0" i="0" dirty="0">
+                <a:solidFill>
+                  <a:schemeClr val="bg1"/>
+                </a:solidFill>
+                <a:effectLst/>
+                <a:latin typeface="Arial" panose="020B0604020202020204" pitchFamily="34" charset="0"/>
+                <a:cs typeface="Arial" panose="020B0604020202020204" pitchFamily="34" charset="0"/>
+              </a:rPr>
+              <a:t>. </a:t>
+            </a:r>
+            <a:r>
+              <a:rPr lang="en-US" sz="1200" b="0" i="0" dirty="0" err="1">
+                <a:solidFill>
+                  <a:schemeClr val="bg1"/>
+                </a:solidFill>
+                <a:effectLst/>
+                <a:latin typeface="Arial" panose="020B0604020202020204" pitchFamily="34" charset="0"/>
+                <a:cs typeface="Arial" panose="020B0604020202020204" pitchFamily="34" charset="0"/>
+              </a:rPr>
+              <a:t>Wavelab</a:t>
+            </a:r>
+            <a:r>
+              <a:rPr lang="en-US" sz="1200" b="0" i="0" dirty="0">
+                <a:solidFill>
+                  <a:schemeClr val="bg1"/>
+                </a:solidFill>
+                <a:effectLst/>
+                <a:latin typeface="Arial" panose="020B0604020202020204" pitchFamily="34" charset="0"/>
+                <a:cs typeface="Arial" panose="020B0604020202020204" pitchFamily="34" charset="0"/>
+              </a:rPr>
+              <a:t> and reproducible research. In </a:t>
+            </a:r>
+            <a:r>
+              <a:rPr lang="en-US" sz="1200" b="0" i="1" dirty="0">
+                <a:solidFill>
+                  <a:schemeClr val="bg1"/>
+                </a:solidFill>
+                <a:effectLst/>
+                <a:latin typeface="Arial" panose="020B0604020202020204" pitchFamily="34" charset="0"/>
+                <a:cs typeface="Arial" panose="020B0604020202020204" pitchFamily="34" charset="0"/>
+              </a:rPr>
+              <a:t>Wavelets and Statistics</a:t>
+            </a:r>
+            <a:r>
+              <a:rPr lang="en-US" sz="1200" b="0" i="0" dirty="0">
+                <a:solidFill>
+                  <a:schemeClr val="bg1"/>
+                </a:solidFill>
+                <a:effectLst/>
+                <a:latin typeface="Arial" panose="020B0604020202020204" pitchFamily="34" charset="0"/>
+                <a:cs typeface="Arial" panose="020B0604020202020204" pitchFamily="34" charset="0"/>
+              </a:rPr>
+              <a:t>, ed. A Antoniadis, pp. 55–81. New York: Springer-Verlag</a:t>
+            </a:r>
+            <a:endParaRPr lang="en-US" sz="1200" dirty="0">
+              <a:solidFill>
+                <a:schemeClr val="bg1"/>
+              </a:solidFill>
+              <a:latin typeface="Arial" panose="020B0604020202020204" pitchFamily="34" charset="0"/>
+              <a:cs typeface="Arial" panose="020B0604020202020204" pitchFamily="34" charset="0"/>
+            </a:endParaRPr>
+          </a:p>
+        </p:txBody>
+      </p:sp>
+      <p:sp>
+        <p:nvSpPr>
+          <p:cNvPr id="7" name="TextBox 6">
+            <a:extLst>
+              <a:ext uri="{FF2B5EF4-FFF2-40B4-BE49-F238E27FC236}">
+                <a16:creationId xmlns:a16="http://schemas.microsoft.com/office/drawing/2014/main" id="{F569973B-3AF2-AA6C-C385-36C0D4B7C826}"/>
+              </a:ext>
+            </a:extLst>
+          </p:cNvPr>
+          <p:cNvSpPr txBox="1"/>
+          <p:nvPr/>
+        </p:nvSpPr>
+        <p:spPr>
+          <a:xfrm>
+            <a:off x="3886200" y="4343400"/>
+            <a:ext cx="4572000" cy="707886"/>
+          </a:xfrm>
+          <a:prstGeom prst="rect">
+            <a:avLst/>
+          </a:prstGeom>
+          <a:noFill/>
+        </p:spPr>
+        <p:txBody>
+          <a:bodyPr wrap="square">
+            <a:spAutoFit/>
+          </a:bodyPr>
+          <a:lstStyle/>
+          <a:p>
+            <a:r>
+              <a:rPr lang="en-US" sz="2000" dirty="0" err="1">
+                <a:solidFill>
+                  <a:schemeClr val="bg1"/>
+                </a:solidFill>
+              </a:rPr>
+              <a:t>Buckheit</a:t>
+            </a:r>
+            <a:r>
+              <a:rPr lang="en-US" sz="2000" dirty="0">
+                <a:solidFill>
+                  <a:schemeClr val="bg1"/>
+                </a:solidFill>
+              </a:rPr>
+              <a:t> and </a:t>
+            </a:r>
+            <a:r>
+              <a:rPr lang="en-US" sz="2000" dirty="0" err="1">
+                <a:solidFill>
+                  <a:schemeClr val="bg1"/>
+                </a:solidFill>
+              </a:rPr>
+              <a:t>Donoho</a:t>
+            </a:r>
+            <a:r>
+              <a:rPr lang="en-US" sz="2000" dirty="0">
+                <a:solidFill>
+                  <a:schemeClr val="bg1"/>
+                </a:solidFill>
+              </a:rPr>
+              <a:t> (1995), paraphrasing John </a:t>
+            </a:r>
+            <a:r>
+              <a:rPr lang="en-US" sz="2000" dirty="0" err="1">
+                <a:solidFill>
+                  <a:schemeClr val="bg1"/>
+                </a:solidFill>
+              </a:rPr>
+              <a:t>Claerbout</a:t>
+            </a:r>
+            <a:endParaRPr lang="en-US" sz="2000" dirty="0">
+              <a:solidFill>
+                <a:schemeClr val="bg1"/>
+              </a:solidFill>
+            </a:endParaRPr>
+          </a:p>
+        </p:txBody>
+      </p:sp>
+    </p:spTree>
+    <p:extLst>
+      <p:ext uri="{BB962C8B-B14F-4D97-AF65-F5344CB8AC3E}">
+        <p14:creationId xmlns:p14="http://schemas.microsoft.com/office/powerpoint/2010/main" val="1760448523"/>
+      </p:ext>
+    </p:extLst>
+  </p:cSld>
+  <p:clrMapOvr>
+    <a:masterClrMapping/>
+  </p:clrMapOvr>
+</p:sld>
+</file>
+
+<file path=ppt/slides/slide4.xml><?xml version="1.0" encoding="utf-8"?>
+<p:sld xmlns:a="http://schemas.openxmlformats.org/drawingml/2006/main" xmlns:r="http://schemas.openxmlformats.org/officeDocument/2006/relationships" xmlns:p="http://schemas.openxmlformats.org/presentationml/2006/main">
+  <p:cSld>
+    <p:spTree>
+      <p:nvGrpSpPr>
+        <p:cNvPr id="1" name="">
+          <a:extLst>
+            <a:ext uri="{FF2B5EF4-FFF2-40B4-BE49-F238E27FC236}">
+              <a16:creationId xmlns:a16="http://schemas.microsoft.com/office/drawing/2014/main" id="{9E4A0767-F539-FE49-563B-E4A493700BB9}"/>
+            </a:ext>
+          </a:extLst>
+        </p:cNvPr>
+        <p:cNvGrpSpPr/>
+        <p:nvPr/>
+      </p:nvGrpSpPr>
+      <p:grpSpPr>
+        <a:xfrm>
+          <a:off x="0" y="0"/>
+          <a:ext cx="0" cy="0"/>
+          <a:chOff x="0" y="0"/>
+          <a:chExt cx="0" cy="0"/>
+        </a:xfrm>
+      </p:grpSpPr>
+      <p:sp>
+        <p:nvSpPr>
+          <p:cNvPr id="6" name="Title 1">
+            <a:extLst>
+              <a:ext uri="{FF2B5EF4-FFF2-40B4-BE49-F238E27FC236}">
+                <a16:creationId xmlns:a16="http://schemas.microsoft.com/office/drawing/2014/main" id="{11FEF6DC-15D7-FF53-A807-FEC534208199}"/>
               </a:ext>
             </a:extLst>
           </p:cNvPr>
@@ -8182,484 +8691,6 @@
           <a:p>
             <a:r>
               <a:rPr lang="en-US" kern="0" dirty="0"/>
-              <a:t>Repeatability is critical for good science</a:t>
-            </a:r>
-          </a:p>
-        </p:txBody>
-      </p:sp>
-      <p:sp>
-        <p:nvSpPr>
-          <p:cNvPr id="4" name="TextBox 3">
-            <a:extLst>
-              <a:ext uri="{FF2B5EF4-FFF2-40B4-BE49-F238E27FC236}">
-                <a16:creationId xmlns:a16="http://schemas.microsoft.com/office/drawing/2014/main" id="{D0997DCB-4F21-6F0F-1473-D3B47EE203B4}"/>
-              </a:ext>
-            </a:extLst>
-          </p:cNvPr>
-          <p:cNvSpPr txBox="1"/>
-          <p:nvPr/>
-        </p:nvSpPr>
-        <p:spPr>
-          <a:xfrm>
-            <a:off x="4343400" y="6096000"/>
-            <a:ext cx="4572000" cy="646331"/>
-          </a:xfrm>
-          <a:prstGeom prst="rect">
-            <a:avLst/>
-          </a:prstGeom>
-          <a:noFill/>
-        </p:spPr>
-        <p:txBody>
-          <a:bodyPr wrap="square">
-            <a:spAutoFit/>
-          </a:bodyPr>
-          <a:lstStyle/>
-          <a:p>
-            <a:pPr algn="r"/>
-            <a:r>
-              <a:rPr lang="en-US" sz="1200" b="0" i="0" dirty="0" err="1">
-                <a:solidFill>
-                  <a:schemeClr val="bg1"/>
-                </a:solidFill>
-                <a:effectLst/>
-                <a:latin typeface="Arial" panose="020B0604020202020204" pitchFamily="34" charset="0"/>
-                <a:cs typeface="Arial" panose="020B0604020202020204" pitchFamily="34" charset="0"/>
-              </a:rPr>
-              <a:t>Buckheit</a:t>
-            </a:r>
-            <a:r>
-              <a:rPr lang="en-US" sz="1200" b="0" i="0" dirty="0">
-                <a:solidFill>
-                  <a:schemeClr val="bg1"/>
-                </a:solidFill>
-                <a:effectLst/>
-                <a:latin typeface="Arial" panose="020B0604020202020204" pitchFamily="34" charset="0"/>
-                <a:cs typeface="Arial" panose="020B0604020202020204" pitchFamily="34" charset="0"/>
-              </a:rPr>
-              <a:t> JB, </a:t>
-            </a:r>
-            <a:r>
-              <a:rPr lang="en-US" sz="1200" b="0" i="0" dirty="0" err="1">
-                <a:solidFill>
-                  <a:schemeClr val="bg1"/>
-                </a:solidFill>
-                <a:effectLst/>
-                <a:latin typeface="Arial" panose="020B0604020202020204" pitchFamily="34" charset="0"/>
-                <a:cs typeface="Arial" panose="020B0604020202020204" pitchFamily="34" charset="0"/>
-              </a:rPr>
-              <a:t>Donoho</a:t>
-            </a:r>
-            <a:r>
-              <a:rPr lang="en-US" sz="1200" b="0" i="0" dirty="0">
-                <a:solidFill>
-                  <a:schemeClr val="bg1"/>
-                </a:solidFill>
-                <a:effectLst/>
-                <a:latin typeface="Arial" panose="020B0604020202020204" pitchFamily="34" charset="0"/>
-                <a:cs typeface="Arial" panose="020B0604020202020204" pitchFamily="34" charset="0"/>
-              </a:rPr>
-              <a:t> DL. </a:t>
-            </a:r>
-            <a:r>
-              <a:rPr lang="en-US" sz="1200" b="1" i="0" dirty="0">
-                <a:solidFill>
-                  <a:schemeClr val="bg1"/>
-                </a:solidFill>
-                <a:effectLst/>
-                <a:latin typeface="Arial" panose="020B0604020202020204" pitchFamily="34" charset="0"/>
-                <a:cs typeface="Arial" panose="020B0604020202020204" pitchFamily="34" charset="0"/>
-              </a:rPr>
-              <a:t>1995</a:t>
-            </a:r>
-            <a:r>
-              <a:rPr lang="en-US" sz="1200" b="0" i="0" dirty="0">
-                <a:solidFill>
-                  <a:schemeClr val="bg1"/>
-                </a:solidFill>
-                <a:effectLst/>
-                <a:latin typeface="Arial" panose="020B0604020202020204" pitchFamily="34" charset="0"/>
-                <a:cs typeface="Arial" panose="020B0604020202020204" pitchFamily="34" charset="0"/>
-              </a:rPr>
-              <a:t>. </a:t>
-            </a:r>
-            <a:r>
-              <a:rPr lang="en-US" sz="1200" b="0" i="0" dirty="0" err="1">
-                <a:solidFill>
-                  <a:schemeClr val="bg1"/>
-                </a:solidFill>
-                <a:effectLst/>
-                <a:latin typeface="Arial" panose="020B0604020202020204" pitchFamily="34" charset="0"/>
-                <a:cs typeface="Arial" panose="020B0604020202020204" pitchFamily="34" charset="0"/>
-              </a:rPr>
-              <a:t>Wavelab</a:t>
-            </a:r>
-            <a:r>
-              <a:rPr lang="en-US" sz="1200" b="0" i="0" dirty="0">
-                <a:solidFill>
-                  <a:schemeClr val="bg1"/>
-                </a:solidFill>
-                <a:effectLst/>
-                <a:latin typeface="Arial" panose="020B0604020202020204" pitchFamily="34" charset="0"/>
-                <a:cs typeface="Arial" panose="020B0604020202020204" pitchFamily="34" charset="0"/>
-              </a:rPr>
-              <a:t> and reproducible research. In </a:t>
-            </a:r>
-            <a:r>
-              <a:rPr lang="en-US" sz="1200" b="0" i="1" dirty="0">
-                <a:solidFill>
-                  <a:schemeClr val="bg1"/>
-                </a:solidFill>
-                <a:effectLst/>
-                <a:latin typeface="Arial" panose="020B0604020202020204" pitchFamily="34" charset="0"/>
-                <a:cs typeface="Arial" panose="020B0604020202020204" pitchFamily="34" charset="0"/>
-              </a:rPr>
-              <a:t>Wavelets and Statistics</a:t>
-            </a:r>
-            <a:r>
-              <a:rPr lang="en-US" sz="1200" b="0" i="0" dirty="0">
-                <a:solidFill>
-                  <a:schemeClr val="bg1"/>
-                </a:solidFill>
-                <a:effectLst/>
-                <a:latin typeface="Arial" panose="020B0604020202020204" pitchFamily="34" charset="0"/>
-                <a:cs typeface="Arial" panose="020B0604020202020204" pitchFamily="34" charset="0"/>
-              </a:rPr>
-              <a:t>, ed. A Antoniadis, pp. 55–81. New York: Springer-Verlag</a:t>
-            </a:r>
-            <a:endParaRPr lang="en-US" sz="1200" dirty="0">
-              <a:solidFill>
-                <a:schemeClr val="bg1"/>
-              </a:solidFill>
-              <a:latin typeface="Arial" panose="020B0604020202020204" pitchFamily="34" charset="0"/>
-              <a:cs typeface="Arial" panose="020B0604020202020204" pitchFamily="34" charset="0"/>
-            </a:endParaRPr>
-          </a:p>
-        </p:txBody>
-      </p:sp>
-      <p:sp>
-        <p:nvSpPr>
-          <p:cNvPr id="7" name="TextBox 6">
-            <a:extLst>
-              <a:ext uri="{FF2B5EF4-FFF2-40B4-BE49-F238E27FC236}">
-                <a16:creationId xmlns:a16="http://schemas.microsoft.com/office/drawing/2014/main" id="{F569973B-3AF2-AA6C-C385-36C0D4B7C826}"/>
-              </a:ext>
-            </a:extLst>
-          </p:cNvPr>
-          <p:cNvSpPr txBox="1"/>
-          <p:nvPr/>
-        </p:nvSpPr>
-        <p:spPr>
-          <a:xfrm>
-            <a:off x="3886200" y="4343400"/>
-            <a:ext cx="4572000" cy="707886"/>
-          </a:xfrm>
-          <a:prstGeom prst="rect">
-            <a:avLst/>
-          </a:prstGeom>
-          <a:noFill/>
-        </p:spPr>
-        <p:txBody>
-          <a:bodyPr wrap="square">
-            <a:spAutoFit/>
-          </a:bodyPr>
-          <a:lstStyle/>
-          <a:p>
-            <a:r>
-              <a:rPr lang="en-US" sz="2000" dirty="0" err="1">
-                <a:solidFill>
-                  <a:schemeClr val="bg1"/>
-                </a:solidFill>
-              </a:rPr>
-              <a:t>Buckheit</a:t>
-            </a:r>
-            <a:r>
-              <a:rPr lang="en-US" sz="2000" dirty="0">
-                <a:solidFill>
-                  <a:schemeClr val="bg1"/>
-                </a:solidFill>
-              </a:rPr>
-              <a:t> and </a:t>
-            </a:r>
-            <a:r>
-              <a:rPr lang="en-US" sz="2000" dirty="0" err="1">
-                <a:solidFill>
-                  <a:schemeClr val="bg1"/>
-                </a:solidFill>
-              </a:rPr>
-              <a:t>Donoho</a:t>
-            </a:r>
-            <a:r>
-              <a:rPr lang="en-US" sz="2000" dirty="0">
-                <a:solidFill>
-                  <a:schemeClr val="bg1"/>
-                </a:solidFill>
-              </a:rPr>
-              <a:t> (1995), paraphrasing John </a:t>
-            </a:r>
-            <a:r>
-              <a:rPr lang="en-US" sz="2000" dirty="0" err="1">
-                <a:solidFill>
-                  <a:schemeClr val="bg1"/>
-                </a:solidFill>
-              </a:rPr>
-              <a:t>Claerbout</a:t>
-            </a:r>
-            <a:endParaRPr lang="en-US" sz="2000" dirty="0">
-              <a:solidFill>
-                <a:schemeClr val="bg1"/>
-              </a:solidFill>
-            </a:endParaRPr>
-          </a:p>
-        </p:txBody>
-      </p:sp>
-    </p:spTree>
-    <p:extLst>
-      <p:ext uri="{BB962C8B-B14F-4D97-AF65-F5344CB8AC3E}">
-        <p14:creationId xmlns:p14="http://schemas.microsoft.com/office/powerpoint/2010/main" val="1760448523"/>
-      </p:ext>
-    </p:extLst>
-  </p:cSld>
-  <p:clrMapOvr>
-    <a:masterClrMapping/>
-  </p:clrMapOvr>
-</p:sld>
-</file>
-
-<file path=ppt/slides/slide4.xml><?xml version="1.0" encoding="utf-8"?>
-<p:sld xmlns:a="http://schemas.openxmlformats.org/drawingml/2006/main" xmlns:r="http://schemas.openxmlformats.org/officeDocument/2006/relationships" xmlns:p="http://schemas.openxmlformats.org/presentationml/2006/main">
-  <p:cSld>
-    <p:spTree>
-      <p:nvGrpSpPr>
-        <p:cNvPr id="1" name="">
-          <a:extLst>
-            <a:ext uri="{FF2B5EF4-FFF2-40B4-BE49-F238E27FC236}">
-              <a16:creationId xmlns:a16="http://schemas.microsoft.com/office/drawing/2014/main" id="{9E4A0767-F539-FE49-563B-E4A493700BB9}"/>
-            </a:ext>
-          </a:extLst>
-        </p:cNvPr>
-        <p:cNvGrpSpPr/>
-        <p:nvPr/>
-      </p:nvGrpSpPr>
-      <p:grpSpPr>
-        <a:xfrm>
-          <a:off x="0" y="0"/>
-          <a:ext cx="0" cy="0"/>
-          <a:chOff x="0" y="0"/>
-          <a:chExt cx="0" cy="0"/>
-        </a:xfrm>
-      </p:grpSpPr>
-      <p:sp>
-        <p:nvSpPr>
-          <p:cNvPr id="6" name="Title 1">
-            <a:extLst>
-              <a:ext uri="{FF2B5EF4-FFF2-40B4-BE49-F238E27FC236}">
-                <a16:creationId xmlns:a16="http://schemas.microsoft.com/office/drawing/2014/main" id="{11FEF6DC-15D7-FF53-A807-FEC534208199}"/>
-              </a:ext>
-            </a:extLst>
-          </p:cNvPr>
-          <p:cNvSpPr txBox="1">
-            <a:spLocks/>
-          </p:cNvSpPr>
-          <p:nvPr/>
-        </p:nvSpPr>
-        <p:spPr bwMode="auto">
-          <a:xfrm>
-            <a:off x="304800" y="115669"/>
-            <a:ext cx="8305800" cy="1143000"/>
-          </a:xfrm>
-          <a:prstGeom prst="rect">
-            <a:avLst/>
-          </a:prstGeom>
-          <a:noFill/>
-          <a:ln>
-            <a:noFill/>
-          </a:ln>
-          <a:effectLst/>
-          <a:extLst>
-            <a:ext uri="{909E8E84-426E-40dd-AFC4-6F175D3DCCD1}">
-              <a14:hiddenFill xmlns:a14="http://schemas.microsoft.com/office/drawing/2010/main" xmlns="">
-                <a:solidFill>
-                  <a:schemeClr val="accent1"/>
-                </a:solidFill>
-              </a14:hiddenFill>
-            </a:ext>
-            <a:ext uri="{91240B29-F687-4f45-9708-019B960494DF}">
-              <a14:hiddenLine xmlns:a14="http://schemas.microsoft.com/office/drawing/2010/main" xmlns="" w="12700">
-                <a:solidFill>
-                  <a:schemeClr val="tx1"/>
-                </a:solidFill>
-                <a:miter lim="800000"/>
-                <a:headEnd/>
-                <a:tailEnd/>
-              </a14:hiddenLine>
-            </a:ext>
-            <a:ext uri="{AF507438-7753-43e0-B8FC-AC1667EBCBE1}">
-              <a14:hiddenEffects xmlns:a14="http://schemas.microsoft.com/office/drawing/2010/main" xmlns="">
-                <a:effectLst>
-                  <a:outerShdw blurRad="63500" dist="38099" dir="2700000" algn="ctr" rotWithShape="0">
-                    <a:schemeClr val="bg2">
-                      <a:alpha val="74998"/>
-                    </a:schemeClr>
-                  </a:outerShdw>
-                </a:effectLst>
-              </a14:hiddenEffects>
-            </a:ext>
-            <a:ext uri="{FAA26D3D-D897-4be2-8F04-BA451C77F1D7}">
-              <ma14:placeholderFlag xmlns:ma14="http://schemas.microsoft.com/office/mac/drawingml/2011/main" xmlns="" val="1"/>
-            </a:ext>
-          </a:extLst>
-        </p:spPr>
-        <p:txBody>
-          <a:bodyPr vert="horz" wrap="square" lIns="90488" tIns="44450" rIns="90488" bIns="44450" numCol="1" anchor="ctr" anchorCtr="0" compatLnSpc="1">
-            <a:prstTxWarp prst="textNoShape">
-              <a:avLst/>
-            </a:prstTxWarp>
-          </a:bodyPr>
-          <a:lstStyle>
-            <a:lvl1pPr algn="l" rtl="0" eaLnBrk="0" fontAlgn="base" hangingPunct="0">
-              <a:spcBef>
-                <a:spcPct val="0"/>
-              </a:spcBef>
-              <a:spcAft>
-                <a:spcPct val="0"/>
-              </a:spcAft>
-              <a:defRPr sz="3600" b="1">
-                <a:solidFill>
-                  <a:srgbClr val="FFFF99"/>
-                </a:solidFill>
-                <a:latin typeface="+mj-lt"/>
-                <a:ea typeface="+mj-ea"/>
-                <a:cs typeface="ＭＳ Ｐゴシック" charset="0"/>
-              </a:defRPr>
-            </a:lvl1pPr>
-            <a:lvl2pPr algn="l" rtl="0" eaLnBrk="0" fontAlgn="base" hangingPunct="0">
-              <a:spcBef>
-                <a:spcPct val="0"/>
-              </a:spcBef>
-              <a:spcAft>
-                <a:spcPct val="0"/>
-              </a:spcAft>
-              <a:defRPr sz="3600" b="1">
-                <a:solidFill>
-                  <a:srgbClr val="FFFF99"/>
-                </a:solidFill>
-                <a:latin typeface="Arial" charset="0"/>
-                <a:ea typeface="ＭＳ Ｐゴシック" charset="0"/>
-                <a:cs typeface="ＭＳ Ｐゴシック" charset="0"/>
-              </a:defRPr>
-            </a:lvl2pPr>
-            <a:lvl3pPr algn="l" rtl="0" eaLnBrk="0" fontAlgn="base" hangingPunct="0">
-              <a:spcBef>
-                <a:spcPct val="0"/>
-              </a:spcBef>
-              <a:spcAft>
-                <a:spcPct val="0"/>
-              </a:spcAft>
-              <a:defRPr sz="3600" b="1">
-                <a:solidFill>
-                  <a:srgbClr val="FFFF99"/>
-                </a:solidFill>
-                <a:latin typeface="Arial" charset="0"/>
-                <a:ea typeface="ＭＳ Ｐゴシック" charset="0"/>
-                <a:cs typeface="ＭＳ Ｐゴシック" charset="0"/>
-              </a:defRPr>
-            </a:lvl3pPr>
-            <a:lvl4pPr algn="l" rtl="0" eaLnBrk="0" fontAlgn="base" hangingPunct="0">
-              <a:spcBef>
-                <a:spcPct val="0"/>
-              </a:spcBef>
-              <a:spcAft>
-                <a:spcPct val="0"/>
-              </a:spcAft>
-              <a:defRPr sz="3600" b="1">
-                <a:solidFill>
-                  <a:srgbClr val="FFFF99"/>
-                </a:solidFill>
-                <a:latin typeface="Arial" charset="0"/>
-                <a:ea typeface="ＭＳ Ｐゴシック" charset="0"/>
-                <a:cs typeface="ＭＳ Ｐゴシック" charset="0"/>
-              </a:defRPr>
-            </a:lvl4pPr>
-            <a:lvl5pPr algn="l" rtl="0" eaLnBrk="0" fontAlgn="base" hangingPunct="0">
-              <a:spcBef>
-                <a:spcPct val="0"/>
-              </a:spcBef>
-              <a:spcAft>
-                <a:spcPct val="0"/>
-              </a:spcAft>
-              <a:defRPr sz="3600" b="1">
-                <a:solidFill>
-                  <a:srgbClr val="FFFF99"/>
-                </a:solidFill>
-                <a:latin typeface="Arial" charset="0"/>
-                <a:ea typeface="ＭＳ Ｐゴシック" charset="0"/>
-                <a:cs typeface="ＭＳ Ｐゴシック" charset="0"/>
-              </a:defRPr>
-            </a:lvl5pPr>
-            <a:lvl6pPr marL="457200" algn="l" rtl="0" eaLnBrk="0" fontAlgn="base" hangingPunct="0">
-              <a:spcBef>
-                <a:spcPct val="0"/>
-              </a:spcBef>
-              <a:spcAft>
-                <a:spcPct val="0"/>
-              </a:spcAft>
-              <a:defRPr sz="3600" b="1">
-                <a:solidFill>
-                  <a:srgbClr val="FFFF99"/>
-                </a:solidFill>
-                <a:latin typeface="Arial" charset="0"/>
-                <a:ea typeface="ＭＳ Ｐゴシック" charset="0"/>
-              </a:defRPr>
-            </a:lvl6pPr>
-            <a:lvl7pPr marL="914400" algn="l" rtl="0" eaLnBrk="0" fontAlgn="base" hangingPunct="0">
-              <a:spcBef>
-                <a:spcPct val="0"/>
-              </a:spcBef>
-              <a:spcAft>
-                <a:spcPct val="0"/>
-              </a:spcAft>
-              <a:defRPr sz="3600" b="1">
-                <a:solidFill>
-                  <a:srgbClr val="FFFF99"/>
-                </a:solidFill>
-                <a:latin typeface="Arial" charset="0"/>
-                <a:ea typeface="ＭＳ Ｐゴシック" charset="0"/>
-              </a:defRPr>
-            </a:lvl7pPr>
-            <a:lvl8pPr marL="1371600" algn="l" rtl="0" eaLnBrk="0" fontAlgn="base" hangingPunct="0">
-              <a:spcBef>
-                <a:spcPct val="0"/>
-              </a:spcBef>
-              <a:spcAft>
-                <a:spcPct val="0"/>
-              </a:spcAft>
-              <a:defRPr sz="3600" b="1">
-                <a:solidFill>
-                  <a:srgbClr val="FFFF99"/>
-                </a:solidFill>
-                <a:latin typeface="Arial" charset="0"/>
-                <a:ea typeface="ＭＳ Ｐゴシック" charset="0"/>
-              </a:defRPr>
-            </a:lvl8pPr>
-            <a:lvl9pPr marL="1828800" algn="l" rtl="0" eaLnBrk="0" fontAlgn="base" hangingPunct="0">
-              <a:spcBef>
-                <a:spcPct val="0"/>
-              </a:spcBef>
-              <a:spcAft>
-                <a:spcPct val="0"/>
-              </a:spcAft>
-              <a:defRPr sz="3600" b="1">
-                <a:solidFill>
-                  <a:srgbClr val="FFFF99"/>
-                </a:solidFill>
-                <a:latin typeface="Arial" charset="0"/>
-                <a:ea typeface="ＭＳ Ｐゴシック" charset="0"/>
-              </a:defRPr>
-            </a:lvl9pPr>
-          </a:lstStyle>
-          <a:p>
-            <a:r>
-              <a:rPr lang="en-US" kern="0" dirty="0"/>
               <a:t>Other benefits of open science and repeatability</a:t>
             </a:r>
           </a:p>
@@ -9509,14 +9540,13 @@
         </p:nvPicPr>
         <p:blipFill>
           <a:blip r:embed="rId3"/>
-          <a:stretch>
-            <a:fillRect/>
-          </a:stretch>
+          <a:srcRect/>
+          <a:stretch/>
         </p:blipFill>
         <p:spPr>
           <a:xfrm>
-            <a:off x="70782" y="1600200"/>
-            <a:ext cx="9002436" cy="3124200"/>
+            <a:off x="196722" y="1600200"/>
+            <a:ext cx="8750555" cy="3124200"/>
           </a:xfrm>
           <a:prstGeom prst="rect">
             <a:avLst/>
@@ -9842,7 +9872,7 @@
         <a:effectLst/>
         <a:extLst>
           <a:ext uri="{AF507438-7753-43e0-B8FC-AC1667EBCBE1}">
-            <a14:hiddenEffects xmlns="" xmlns:a14="http://schemas.microsoft.com/office/drawing/2010/main">
+            <a14:hiddenEffects xmlns:a14="http://schemas.microsoft.com/office/drawing/2010/main" xmlns="">
               <a:effectLst>
                 <a:outerShdw blurRad="63500" dist="38099" dir="2700000" algn="ctr" rotWithShape="0">
                   <a:schemeClr val="bg2">
@@ -9918,7 +9948,7 @@
         <a:effectLst/>
         <a:extLst>
           <a:ext uri="{AF507438-7753-43e0-B8FC-AC1667EBCBE1}">
-            <a14:hiddenEffects xmlns="" xmlns:a14="http://schemas.microsoft.com/office/drawing/2010/main">
+            <a14:hiddenEffects xmlns:a14="http://schemas.microsoft.com/office/drawing/2010/main" xmlns="">
               <a:effectLst>
                 <a:outerShdw blurRad="63500" dist="38099" dir="2700000" algn="ctr" rotWithShape="0">
                   <a:schemeClr val="bg2">
@@ -10896,4 +10926,10 @@
   </a:objectDefaults>
   <a:extraClrSchemeLst/>
 </a:theme>
+</file>
+
+<file path=docMetadata/LabelInfo.xml><?xml version="1.0" encoding="utf-8"?>
+<clbl:labelList xmlns:clbl="http://schemas.microsoft.com/office/2020/mipLabelMetadata">
+  <clbl:label id="{6dd02d64-b7f3-43f7-a145-cfd68d338edf}" enabled="1" method="Standard" siteId="{0693b5ba-4b18-4d7b-9341-f32f400a5494}" contentBits="0" removed="0"/>
+</clbl:labelList>
 </file>
</xml_diff>